<commit_message>
Document Windows 10 verification (VirtualBox VM, full flow, no issues)
Closes the previously-named open item: the supervisor asked whether the
system works on Windows 10; the codebase had no version-specific
dependency but had never actually been run there. Now verified end to
end via a real test, not just architectural inference.
</commit_message>
<xml_diff>
--- a/docs/presentation/Migration_Wizard_Praktikum_Presentation.pptx
+++ b/docs/presentation/Migration_Wizard_Praktikum_Presentation.pptx
@@ -8218,6 +8218,41 @@
                 <a:latin typeface="Segoe UI"/>
               </a:rPr>
               <a:t>) · 3,595 LOC (tests) · 89 files · MIT licensed</a:t>
+            </a:r>
+          </a:p>
+        </p:txBody>
+      </p:sp>
+      <p:sp>
+        <p:nvSpPr>
+          <p:cNvPr id="27" name="TextBox 26"/>
+          <p:cNvSpPr txBox="1"/>
+          <p:nvPr/>
+        </p:nvSpPr>
+        <p:spPr>
+          <a:xfrm>
+            <a:off x="1554480" y="5650992"/>
+            <a:ext cx="9052560" cy="365760"/>
+          </a:xfrm>
+          <a:prstGeom prst="rect">
+            <a:avLst/>
+          </a:prstGeom>
+          <a:noFill/>
+        </p:spPr>
+        <p:txBody>
+          <a:bodyPr wrap="square">
+            <a:spAutoFit/>
+          </a:bodyPr>
+          <a:lstStyle/>
+          <a:p>
+            <a:pPr algn="l"/>
+            <a:r>
+              <a:rPr sz="1300" i="1">
+                <a:solidFill>
+                  <a:srgbClr val="3F3F3F"/>
+                </a:solidFill>
+                <a:latin typeface="Segoe UI"/>
+              </a:rPr>
+              <a:t>Verified on Windows 10 and Windows 11 (VirtualBox VM) — full scan-to-restore flow, no issues.</a:t>
             </a:r>
           </a:p>
         </p:txBody>

</xml_diff>

<commit_message>
Add telemetry market report citation to References (slide 4's source)
Verified the report title is real (Global Telemetry Market Report,
The Business Research Company) but the exact URL on slide 4 returns
404 -- likely superseded by a newer yearly edition. Cited by title and
publisher only, no dead link, per the user's choice.
</commit_message>
<xml_diff>
--- a/docs/presentation/Migration_Wizard_Praktikum_Presentation.pptx
+++ b/docs/presentation/Migration_Wizard_Praktikum_Presentation.pptx
@@ -21281,7 +21281,7 @@
         </p:nvSpPr>
         <p:spPr>
           <a:xfrm>
-            <a:off x="822960" y="5074920"/>
+            <a:off x="822960" y="5669280"/>
             <a:ext cx="10515600" cy="457200"/>
           </a:xfrm>
           <a:prstGeom prst="rect">
@@ -21304,6 +21304,40 @@
                 <a:latin typeface="Segoe UI"/>
               </a:rPr>
               <a:t>Full bibliography: Arthur, J. — Digital Sovereignty Through Semi-Automated OS Migration (term paper).</a:t>
+            </a:r>
+          </a:p>
+        </p:txBody>
+      </p:sp>
+      <p:sp>
+        <p:nvSpPr>
+          <p:cNvPr id="11" name="TextBox 10"/>
+          <p:cNvSpPr txBox="1"/>
+          <p:nvPr/>
+        </p:nvSpPr>
+        <p:spPr>
+          <a:xfrm>
+            <a:off x="822960" y="4892040"/>
+            <a:ext cx="10515600" cy="411480"/>
+          </a:xfrm>
+          <a:prstGeom prst="rect">
+            <a:avLst/>
+          </a:prstGeom>
+          <a:noFill/>
+        </p:spPr>
+        <p:txBody>
+          <a:bodyPr wrap="square">
+            <a:spAutoFit/>
+          </a:bodyPr>
+          <a:lstStyle/>
+          <a:p>
+            <a:r>
+              <a:rPr sz="1450" b="0">
+                <a:solidFill>
+                  <a:srgbClr val="1A1A1A"/>
+                </a:solidFill>
+                <a:latin typeface="Segoe UI"/>
+              </a:rPr>
+              <a:t>•  The Business Research Company (2026). Global Telemetry Market Report.</a:t>
             </a:r>
           </a:p>
         </p:txBody>

</xml_diff>

<commit_message>
Correct packaging claim: POC packaged both platforms, just manually
The deck and walkthrough doc claimed the proof of concept packaged
Linux only. Per correction: it packaged both Windows and Linux, as two
separate manually-built binaries with no auto-embedding -- that's the
actual distinguishing fact vs this project's auto-embed mechanism, not
platform count. Fixed slide 8's icon row, slide 18's comparison table,
and both references in PROJECT_WALKTHROUGH.md.
</commit_message>
<xml_diff>
--- a/docs/presentation/Migration_Wizard_Praktikum_Presentation.pptx
+++ b/docs/presentation/Migration_Wizard_Praktikum_Presentation.pptx
@@ -13623,7 +13623,7 @@
                           </a:solidFill>
                           <a:latin typeface="Segoe UI"/>
                         </a:rPr>
-                        <a:t>1 (Linux)</a:t>
+                        <a:t>2 (Win + Linux, manual)</a:t>
                       </a:r>
                     </a:p>
                   </a:txBody>
@@ -13669,7 +13669,7 @@
                           </a:solidFill>
                           <a:latin typeface="Segoe UI"/>
                         </a:rPr>
-                        <a:t>1 → 2</a:t>
+                        <a:t>manual → automatic</a:t>
                       </a:r>
                     </a:p>
                   </a:txBody>
@@ -23989,7 +23989,7 @@
                     <a:srgbClr val="FFFFFF"/>
                   </a:solidFill>
                 </a:rPr>
-                <a:t>🐧</a:t>
+                <a:t>📦</a:t>
               </a:r>
             </a:p>
           </p:txBody>
@@ -24024,7 +24024,7 @@
                   </a:solidFill>
                   <a:latin typeface="Segoe UI"/>
                 </a:rPr>
-                <a:t>Linux-only</a:t>
+                <a:t>Two binaries</a:t>
               </a:r>
             </a:p>
           </p:txBody>
@@ -24063,23 +24063,8 @@
                   </a:solidFill>
                   <a:latin typeface="Segoe UI"/>
                 </a:rPr>
-                <a:t>packaging; one</a:t>
-              </a:r>
-            </a:p>
-            <a:p>
-              <a:pPr algn="ctr">
-                <a:lnSpc>
-                  <a:spcPct val="115000"/>
-                </a:lnSpc>
-              </a:pPr>
-              <a:r>
-                <a:rPr sz="1250" b="0" i="0">
-                  <a:solidFill>
-                    <a:srgbClr val="3F3F3F"/>
-                  </a:solidFill>
-                  <a:latin typeface="Segoe UI"/>
-                </a:rPr>
-                <a:t>22.5MB binary</a:t>
+                <a:t>built separately,
+no auto-embed</a:t>
               </a:r>
             </a:p>
           </p:txBody>

</xml_diff>

<commit_message>
Remove redundant 'What the project delivers' slide
Every stat on it (238 mappings, 192 tests, 3 modes, 2 platforms) was
already stated on earlier slides, its screenshot was a literal
duplicate of the one on the workflow slide (same image hash), and its
growth chart claimed a 149-entry baseline that contradicted the
comparison table's verified 25-entry proof-of-concept baseline.
Removing it loses no unique content and fixes the inconsistency.
</commit_message>
<xml_diff>
--- a/docs/presentation/Migration_Wizard_Praktikum_Presentation.pptx
+++ b/docs/presentation/Migration_Wizard_Praktikum_Presentation.pptx
@@ -5,10 +5,10 @@
     <p:sldMasterId id="2147483651" r:id="rId1"/>
   </p:sldMasterIdLst>
   <p:notesMasterIdLst>
-    <p:notesMasterId r:id="rId30"/>
+    <p:notesMasterId r:id="rId31"/>
   </p:notesMasterIdLst>
   <p:handoutMasterIdLst>
-    <p:handoutMasterId r:id="rId31"/>
+    <p:handoutMasterId r:id="rId32"/>
   </p:handoutMasterIdLst>
   <p:sldIdLst>
     <p:sldId id="256" r:id="rId2"/>
@@ -19,27 +19,26 @@
     <p:sldId id="260" r:id="rId7"/>
     <p:sldId id="261" r:id="rId8"/>
     <p:sldId id="262" r:id="rId9"/>
-    <p:sldId id="286" r:id="rId36"/>
-    <p:sldId id="263" r:id="rId10"/>
-    <p:sldId id="264" r:id="rId11"/>
-    <p:sldId id="265" r:id="rId12"/>
-    <p:sldId id="266" r:id="rId13"/>
-    <p:sldId id="267" r:id="rId14"/>
-    <p:sldId id="268" r:id="rId15"/>
-    <p:sldId id="269" r:id="rId16"/>
-    <p:sldId id="270" r:id="rId17"/>
-    <p:sldId id="271" r:id="rId18"/>
-    <p:sldId id="272" r:id="rId19"/>
-    <p:sldId id="273" r:id="rId20"/>
-    <p:sldId id="274" r:id="rId21"/>
-    <p:sldId id="282" r:id="rId22"/>
-    <p:sldId id="275" r:id="rId23"/>
-    <p:sldId id="283" r:id="rId24"/>
-    <p:sldId id="278" r:id="rId25"/>
-    <p:sldId id="279" r:id="rId26"/>
-    <p:sldId id="284" r:id="rId27"/>
-    <p:sldId id="280" r:id="rId28"/>
-    <p:sldId id="281" r:id="rId29"/>
+    <p:sldId id="286" r:id="rId10"/>
+    <p:sldId id="263" r:id="rId11"/>
+    <p:sldId id="264" r:id="rId12"/>
+    <p:sldId id="265" r:id="rId13"/>
+    <p:sldId id="266" r:id="rId14"/>
+    <p:sldId id="267" r:id="rId15"/>
+    <p:sldId id="268" r:id="rId16"/>
+    <p:sldId id="269" r:id="rId17"/>
+    <p:sldId id="270" r:id="rId18"/>
+    <p:sldId id="271" r:id="rId19"/>
+    <p:sldId id="272" r:id="rId20"/>
+    <p:sldId id="273" r:id="rId21"/>
+    <p:sldId id="274" r:id="rId22"/>
+    <p:sldId id="282" r:id="rId23"/>
+    <p:sldId id="283" r:id="rId25"/>
+    <p:sldId id="278" r:id="rId26"/>
+    <p:sldId id="279" r:id="rId27"/>
+    <p:sldId id="284" r:id="rId28"/>
+    <p:sldId id="280" r:id="rId29"/>
+    <p:sldId id="281" r:id="rId30"/>
   </p:sldIdLst>
   <p:sldSz cx="12192000" cy="6858000"/>
   <p:notesSz cx="6797675" cy="9928225"/>
@@ -897,229 +896,6 @@
 </c:chartSpace>
 </file>
 
-<file path=ppt/charts/chart4.xml><?xml version="1.0" encoding="utf-8"?>
-<c:chartSpace xmlns:c="http://schemas.openxmlformats.org/drawingml/2006/chart" xmlns:a="http://schemas.openxmlformats.org/drawingml/2006/main" xmlns:r="http://schemas.openxmlformats.org/officeDocument/2006/relationships" xmlns:c16r2="http://schemas.microsoft.com/office/drawing/2015/06/chart">
-  <c:date1904 val="0"/>
-  <c:lang val="en-US"/>
-  <c:roundedCorners val="1"/>
-  <c:style val="2"/>
-  <c:chart>
-    <c:title>
-      <c:tx>
-        <c:rich>
-          <a:bodyPr/>
-          <a:lstStyle/>
-          <a:p>
-            <a:r>
-              <a:rPr lang="en-US" sz="1300" b="1"/>
-              <a:t>App mapping table growth</a:t>
-            </a:r>
-          </a:p>
-        </c:rich>
-      </c:tx>
-      <c:overlay val="0"/>
-    </c:title>
-    <c:autoTitleDeleted val="0"/>
-    <c:plotArea>
-      <c:layout/>
-      <c:barChart>
-        <c:barDir val="col"/>
-        <c:grouping val="clustered"/>
-        <c:varyColors val="1"/>
-        <c:ser>
-          <c:idx val="0"/>
-          <c:order val="0"/>
-          <c:tx>
-            <c:strRef>
-              <c:f>Sheet1!$B$1</c:f>
-              <c:strCache>
-                <c:ptCount val="1"/>
-                <c:pt idx="0">
-                  <c:v>App mappings</c:v>
-                </c:pt>
-              </c:strCache>
-            </c:strRef>
-          </c:tx>
-          <c:spPr>
-            <a:solidFill>
-              <a:srgbClr val="008439"/>
-            </a:solidFill>
-            <a:ln>
-              <a:noFill/>
-            </a:ln>
-          </c:spPr>
-          <c:invertIfNegative val="1"/>
-          <c:dLbls>
-            <c:spPr>
-              <a:noFill/>
-              <a:ln>
-                <a:noFill/>
-              </a:ln>
-              <a:effectLst/>
-            </c:spPr>
-            <c:txPr>
-              <a:bodyPr/>
-              <a:lstStyle/>
-              <a:p>
-                <a:pPr>
-                  <a:defRPr sz="1300" b="1">
-                    <a:solidFill>
-                      <a:srgbClr val="1A1A1A"/>
-                    </a:solidFill>
-                  </a:defRPr>
-                </a:pPr>
-                <a:endParaRPr lang="en-GH"/>
-              </a:p>
-            </c:txPr>
-            <c:dLblPos val="outEnd"/>
-            <c:showLegendKey val="0"/>
-            <c:showVal val="1"/>
-            <c:showCatName val="0"/>
-            <c:showSerName val="0"/>
-            <c:showPercent val="0"/>
-            <c:showBubbleSize val="0"/>
-            <c:showLeaderLines val="0"/>
-            <c:extLst>
-              <c:ext xmlns:c15="http://schemas.microsoft.com/office/drawing/2012/chart" uri="{CE6537A1-D6FC-4f65-9D91-7224C49458BB}">
-                <c15:showLeaderLines val="0"/>
-              </c:ext>
-            </c:extLst>
-          </c:dLbls>
-          <c:cat>
-            <c:strRef>
-              <c:f>Sheet1!$A$2:$A$3</c:f>
-              <c:strCache>
-                <c:ptCount val="2"/>
-                <c:pt idx="0">
-                  <c:v>Before</c:v>
-                </c:pt>
-                <c:pt idx="1">
-                  <c:v>Now</c:v>
-                </c:pt>
-              </c:strCache>
-            </c:strRef>
-          </c:cat>
-          <c:val>
-            <c:numRef>
-              <c:f>Sheet1!$B$2:$B$3</c:f>
-              <c:numCache>
-                <c:formatCode>General</c:formatCode>
-                <c:ptCount val="2"/>
-                <c:pt idx="0">
-                  <c:v>149</c:v>
-                </c:pt>
-                <c:pt idx="1">
-                  <c:v>238</c:v>
-                </c:pt>
-              </c:numCache>
-            </c:numRef>
-          </c:val>
-          <c:extLst>
-            <c:ext xmlns:c14="http://schemas.microsoft.com/office/drawing/2007/8/2/chart" uri="{6F2FDCE9-48DA-4B69-8628-5D25D57E5C99}">
-              <c14:invertSolidFillFmt>
-                <c14:spPr xmlns:c14="http://schemas.microsoft.com/office/drawing/2007/8/2/chart">
-                  <a:solidFill>
-                    <a:srgbClr val="FFFFFF"/>
-                  </a:solidFill>
-                  <a:ln>
-                    <a:noFill/>
-                  </a:ln>
-                </c14:spPr>
-              </c14:invertSolidFillFmt>
-            </c:ext>
-            <c:ext xmlns:c16="http://schemas.microsoft.com/office/drawing/2014/chart" uri="{C3380CC4-5D6E-409C-BE32-E72D297353CC}">
-              <c16:uniqueId val="{00000000-B230-492A-AE73-A0CA52B56C80}"/>
-            </c:ext>
-          </c:extLst>
-        </c:ser>
-        <c:dLbls>
-          <c:dLblPos val="outEnd"/>
-          <c:showLegendKey val="0"/>
-          <c:showVal val="1"/>
-          <c:showCatName val="0"/>
-          <c:showSerName val="0"/>
-          <c:showPercent val="0"/>
-          <c:showBubbleSize val="0"/>
-        </c:dLbls>
-        <c:gapWidth val="150"/>
-        <c:axId val="-2068027336"/>
-        <c:axId val="-2113994440"/>
-      </c:barChart>
-      <c:catAx>
-        <c:axId val="-2068027336"/>
-        <c:scaling>
-          <c:orientation val="minMax"/>
-        </c:scaling>
-        <c:delete val="0"/>
-        <c:axPos val="b"/>
-        <c:numFmt formatCode="General" sourceLinked="0"/>
-        <c:majorTickMark val="out"/>
-        <c:minorTickMark val="none"/>
-        <c:tickLblPos val="nextTo"/>
-        <c:spPr>
-          <a:ln>
-            <a:solidFill>
-              <a:srgbClr val="D8DADC"/>
-            </a:solidFill>
-          </a:ln>
-        </c:spPr>
-        <c:txPr>
-          <a:bodyPr/>
-          <a:lstStyle/>
-          <a:p>
-            <a:pPr>
-              <a:defRPr sz="1300">
-                <a:solidFill>
-                  <a:srgbClr val="1A1A1A"/>
-                </a:solidFill>
-              </a:defRPr>
-            </a:pPr>
-            <a:endParaRPr lang="en-GH"/>
-          </a:p>
-        </c:txPr>
-        <c:crossAx val="-2113994440"/>
-        <c:crosses val="autoZero"/>
-        <c:auto val="1"/>
-        <c:lblAlgn val="ctr"/>
-        <c:lblOffset val="100"/>
-        <c:noMultiLvlLbl val="0"/>
-      </c:catAx>
-      <c:valAx>
-        <c:axId val="-2113994440"/>
-        <c:scaling>
-          <c:orientation val="minMax"/>
-        </c:scaling>
-        <c:delete val="1"/>
-        <c:axPos val="l"/>
-        <c:numFmt formatCode="General" sourceLinked="1"/>
-        <c:majorTickMark val="out"/>
-        <c:minorTickMark val="none"/>
-        <c:tickLblPos val="nextTo"/>
-        <c:crossAx val="-2068027336"/>
-        <c:crosses val="autoZero"/>
-        <c:crossBetween val="between"/>
-      </c:valAx>
-    </c:plotArea>
-    <c:plotVisOnly val="1"/>
-    <c:dispBlanksAs val="gap"/>
-    <c:showDLblsOverMax val="1"/>
-  </c:chart>
-  <c:txPr>
-    <a:bodyPr/>
-    <a:lstStyle/>
-    <a:p>
-      <a:pPr>
-        <a:defRPr sz="1800"/>
-      </a:pPr>
-      <a:endParaRPr lang="en-US"/>
-    </a:p>
-  </c:txPr>
-  <c:externalData r:id="rId1">
-    <c:autoUpdate val="0"/>
-  </c:externalData>
-</c:chartSpace>
-</file>
-
 <file path=ppt/handoutMasters/handoutMaster1.xml><?xml version="1.0" encoding="utf-8"?>
 <p:handoutMaster xmlns:a="http://schemas.openxmlformats.org/drawingml/2006/main" xmlns:r="http://schemas.openxmlformats.org/officeDocument/2006/relationships" xmlns:p="http://schemas.openxmlformats.org/presentationml/2006/main">
   <p:cSld>
@@ -1996,7 +1772,7 @@
             <a:fld id="{412C2970-D838-4E16-9F7E-5362C8D6E639}" type="slidenum">
               <a:rPr lang="en-US" smtClean="0"/>
               <a:pPr/>
-              <a:t>9</a:t>
+              <a:t>10</a:t>
             </a:fld>
             <a:endParaRPr lang="en-US"/>
           </a:p>
@@ -2145,7 +1921,7 @@
             <a:fld id="{412C2970-D838-4E16-9F7E-5362C8D6E639}" type="slidenum">
               <a:rPr lang="en-US" smtClean="0"/>
               <a:pPr/>
-              <a:t>12</a:t>
+              <a:t>13</a:t>
             </a:fld>
             <a:endParaRPr lang="en-US"/>
           </a:p>
@@ -2258,7 +2034,7 @@
             <a:fld id="{412C2970-D838-4E16-9F7E-5362C8D6E639}" type="slidenum">
               <a:rPr lang="en-US" smtClean="0"/>
               <a:pPr/>
-              <a:t>17</a:t>
+              <a:t>18</a:t>
             </a:fld>
             <a:endParaRPr lang="en-US"/>
           </a:p>
@@ -2437,7 +2213,7 @@
             <a:fld id="{412C2970-D838-4E16-9F7E-5362C8D6E639}" type="slidenum">
               <a:rPr lang="en-US" smtClean="0"/>
               <a:pPr/>
-              <a:t>18</a:t>
+              <a:t>19</a:t>
             </a:fld>
             <a:endParaRPr lang="en-US"/>
           </a:p>
@@ -12238,7 +12014,7 @@
         </p:nvSpPr>
         <p:spPr>
           <a:xfrm>
-            <a:off x="5015880" y="7245424"/>
+            <a:off x="6126480" y="1612979"/>
             <a:ext cx="5212080" cy="329184"/>
           </a:xfrm>
           <a:prstGeom prst="rect">
@@ -17552,747 +17328,6 @@
 </p:sld>
 </file>
 
-<file path=ppt/slides/slide23.xml><?xml version="1.0" encoding="utf-8"?>
-<p:sld xmlns:a="http://schemas.openxmlformats.org/drawingml/2006/main" xmlns:r="http://schemas.openxmlformats.org/officeDocument/2006/relationships" xmlns:p="http://schemas.openxmlformats.org/presentationml/2006/main">
-  <p:cSld>
-    <p:spTree>
-      <p:nvGrpSpPr>
-        <p:cNvPr id="1" name=""/>
-        <p:cNvGrpSpPr/>
-        <p:nvPr/>
-      </p:nvGrpSpPr>
-      <p:grpSpPr>
-        <a:xfrm>
-          <a:off x="0" y="0"/>
-          <a:ext cx="0" cy="0"/>
-          <a:chOff x="0" y="0"/>
-          <a:chExt cx="0" cy="0"/>
-        </a:xfrm>
-      </p:grpSpPr>
-      <p:sp>
-        <p:nvSpPr>
-          <p:cNvPr id="2" name="TextBox 1"/>
-          <p:cNvSpPr txBox="1"/>
-          <p:nvPr/>
-        </p:nvSpPr>
-        <p:spPr>
-          <a:xfrm>
-            <a:off x="548640" y="274320"/>
-            <a:ext cx="10058400" cy="320040"/>
-          </a:xfrm>
-          <a:prstGeom prst="rect">
-            <a:avLst/>
-          </a:prstGeom>
-          <a:noFill/>
-        </p:spPr>
-        <p:txBody>
-          <a:bodyPr wrap="square">
-            <a:spAutoFit/>
-          </a:bodyPr>
-          <a:lstStyle/>
-          <a:p>
-            <a:pPr algn="l"/>
-            <a:r>
-              <a:rPr sz="1200" b="1" i="0">
-                <a:solidFill>
-                  <a:srgbClr val="063D79"/>
-                </a:solidFill>
-                <a:latin typeface="Segoe UI"/>
-              </a:rPr>
-              <a:t>EVIDENCE</a:t>
-            </a:r>
-          </a:p>
-        </p:txBody>
-      </p:sp>
-      <p:sp>
-        <p:nvSpPr>
-          <p:cNvPr id="3" name="TextBox 2"/>
-          <p:cNvSpPr txBox="1"/>
-          <p:nvPr/>
-        </p:nvSpPr>
-        <p:spPr>
-          <a:xfrm>
-            <a:off x="548640" y="566928"/>
-            <a:ext cx="10972800" cy="685800"/>
-          </a:xfrm>
-          <a:prstGeom prst="rect">
-            <a:avLst/>
-          </a:prstGeom>
-          <a:noFill/>
-        </p:spPr>
-        <p:txBody>
-          <a:bodyPr wrap="square">
-            <a:spAutoFit/>
-          </a:bodyPr>
-          <a:lstStyle/>
-          <a:p>
-            <a:pPr algn="l"/>
-            <a:r>
-              <a:rPr sz="2700" b="1" i="0">
-                <a:solidFill>
-                  <a:srgbClr val="1A1A1A"/>
-                </a:solidFill>
-                <a:latin typeface="Segoe UI"/>
-              </a:rPr>
-              <a:t>What the project delivers</a:t>
-            </a:r>
-          </a:p>
-        </p:txBody>
-      </p:sp>
-      <p:sp>
-        <p:nvSpPr>
-          <p:cNvPr id="4" name="Rectangle 3"/>
-          <p:cNvSpPr/>
-          <p:nvPr/>
-        </p:nvSpPr>
-        <p:spPr>
-          <a:xfrm>
-            <a:off x="548640" y="1207008"/>
-            <a:ext cx="1005840" cy="38100"/>
-          </a:xfrm>
-          <a:prstGeom prst="rect">
-            <a:avLst/>
-          </a:prstGeom>
-          <a:solidFill>
-            <a:srgbClr val="063D79"/>
-          </a:solidFill>
-          <a:ln>
-            <a:noFill/>
-          </a:ln>
-          <a:effectLst/>
-        </p:spPr>
-        <p:style>
-          <a:lnRef idx="1">
-            <a:schemeClr val="accent1"/>
-          </a:lnRef>
-          <a:fillRef idx="3">
-            <a:schemeClr val="accent1"/>
-          </a:fillRef>
-          <a:effectRef idx="2">
-            <a:schemeClr val="accent1"/>
-          </a:effectRef>
-          <a:fontRef idx="minor">
-            <a:schemeClr val="lt1"/>
-          </a:fontRef>
-        </p:style>
-        <p:txBody>
-          <a:bodyPr rtlCol="0" anchor="ctr"/>
-          <a:lstStyle/>
-          <a:p>
-            <a:pPr algn="ctr"/>
-            <a:endParaRPr/>
-          </a:p>
-        </p:txBody>
-      </p:sp>
-      <p:sp>
-        <p:nvSpPr>
-          <p:cNvPr id="5" name="Rounded Rectangle 4"/>
-          <p:cNvSpPr/>
-          <p:nvPr/>
-        </p:nvSpPr>
-        <p:spPr>
-          <a:xfrm>
-            <a:off x="731520" y="1645920"/>
-            <a:ext cx="2514600" cy="1371600"/>
-          </a:xfrm>
-          <a:prstGeom prst="roundRect">
-            <a:avLst>
-              <a:gd name="adj" fmla="val 7000"/>
-            </a:avLst>
-          </a:prstGeom>
-          <a:solidFill>
-            <a:srgbClr val="FFFFFF"/>
-          </a:solidFill>
-          <a:ln w="12700">
-            <a:solidFill>
-              <a:srgbClr val="D8DADC"/>
-            </a:solidFill>
-          </a:ln>
-          <a:effectLst/>
-        </p:spPr>
-        <p:style>
-          <a:lnRef idx="1">
-            <a:schemeClr val="accent1"/>
-          </a:lnRef>
-          <a:fillRef idx="3">
-            <a:schemeClr val="accent1"/>
-          </a:fillRef>
-          <a:effectRef idx="2">
-            <a:schemeClr val="accent1"/>
-          </a:effectRef>
-          <a:fontRef idx="minor">
-            <a:schemeClr val="lt1"/>
-          </a:fontRef>
-        </p:style>
-        <p:txBody>
-          <a:bodyPr rtlCol="0" anchor="ctr"/>
-          <a:lstStyle/>
-          <a:p>
-            <a:pPr algn="ctr"/>
-            <a:endParaRPr/>
-          </a:p>
-        </p:txBody>
-      </p:sp>
-      <p:sp>
-        <p:nvSpPr>
-          <p:cNvPr id="6" name="TextBox 5"/>
-          <p:cNvSpPr txBox="1"/>
-          <p:nvPr/>
-        </p:nvSpPr>
-        <p:spPr>
-          <a:xfrm>
-            <a:off x="731520" y="1783080"/>
-            <a:ext cx="2514600" cy="685800"/>
-          </a:xfrm>
-          <a:prstGeom prst="rect">
-            <a:avLst/>
-          </a:prstGeom>
-          <a:noFill/>
-        </p:spPr>
-        <p:txBody>
-          <a:bodyPr wrap="square">
-            <a:spAutoFit/>
-          </a:bodyPr>
-          <a:lstStyle/>
-          <a:p>
-            <a:pPr algn="ctr"/>
-            <a:r>
-              <a:rPr sz="3200" b="1" i="0">
-                <a:solidFill>
-                  <a:srgbClr val="063D79"/>
-                </a:solidFill>
-                <a:latin typeface="Segoe UI"/>
-              </a:rPr>
-              <a:t>238</a:t>
-            </a:r>
-          </a:p>
-        </p:txBody>
-      </p:sp>
-      <p:sp>
-        <p:nvSpPr>
-          <p:cNvPr id="7" name="TextBox 6"/>
-          <p:cNvSpPr txBox="1"/>
-          <p:nvPr/>
-        </p:nvSpPr>
-        <p:spPr>
-          <a:xfrm>
-            <a:off x="868680" y="2377440"/>
-            <a:ext cx="2240280" cy="457200"/>
-          </a:xfrm>
-          <a:prstGeom prst="rect">
-            <a:avLst/>
-          </a:prstGeom>
-          <a:noFill/>
-        </p:spPr>
-        <p:txBody>
-          <a:bodyPr wrap="square">
-            <a:spAutoFit/>
-          </a:bodyPr>
-          <a:lstStyle/>
-          <a:p>
-            <a:pPr algn="ctr"/>
-            <a:r>
-              <a:rPr sz="1250" b="0" i="0">
-                <a:solidFill>
-                  <a:srgbClr val="1A1A1A"/>
-                </a:solidFill>
-                <a:latin typeface="Segoe UI"/>
-              </a:rPr>
-              <a:t>app mappings</a:t>
-            </a:r>
-          </a:p>
-        </p:txBody>
-      </p:sp>
-      <p:sp>
-        <p:nvSpPr>
-          <p:cNvPr id="8" name="Rounded Rectangle 7"/>
-          <p:cNvSpPr/>
-          <p:nvPr/>
-        </p:nvSpPr>
-        <p:spPr>
-          <a:xfrm>
-            <a:off x="3364992" y="1645920"/>
-            <a:ext cx="2514600" cy="1371600"/>
-          </a:xfrm>
-          <a:prstGeom prst="roundRect">
-            <a:avLst>
-              <a:gd name="adj" fmla="val 7000"/>
-            </a:avLst>
-          </a:prstGeom>
-          <a:solidFill>
-            <a:srgbClr val="FFFFFF"/>
-          </a:solidFill>
-          <a:ln w="12700">
-            <a:solidFill>
-              <a:srgbClr val="D8DADC"/>
-            </a:solidFill>
-          </a:ln>
-          <a:effectLst/>
-        </p:spPr>
-        <p:style>
-          <a:lnRef idx="1">
-            <a:schemeClr val="accent1"/>
-          </a:lnRef>
-          <a:fillRef idx="3">
-            <a:schemeClr val="accent1"/>
-          </a:fillRef>
-          <a:effectRef idx="2">
-            <a:schemeClr val="accent1"/>
-          </a:effectRef>
-          <a:fontRef idx="minor">
-            <a:schemeClr val="lt1"/>
-          </a:fontRef>
-        </p:style>
-        <p:txBody>
-          <a:bodyPr rtlCol="0" anchor="ctr"/>
-          <a:lstStyle/>
-          <a:p>
-            <a:pPr algn="ctr"/>
-            <a:endParaRPr/>
-          </a:p>
-        </p:txBody>
-      </p:sp>
-      <p:sp>
-        <p:nvSpPr>
-          <p:cNvPr id="9" name="TextBox 8"/>
-          <p:cNvSpPr txBox="1"/>
-          <p:nvPr/>
-        </p:nvSpPr>
-        <p:spPr>
-          <a:xfrm>
-            <a:off x="3364992" y="1783080"/>
-            <a:ext cx="2514600" cy="685800"/>
-          </a:xfrm>
-          <a:prstGeom prst="rect">
-            <a:avLst/>
-          </a:prstGeom>
-          <a:noFill/>
-        </p:spPr>
-        <p:txBody>
-          <a:bodyPr wrap="square">
-            <a:spAutoFit/>
-          </a:bodyPr>
-          <a:lstStyle/>
-          <a:p>
-            <a:pPr algn="ctr"/>
-            <a:r>
-              <a:rPr sz="3200" b="1" i="0">
-                <a:solidFill>
-                  <a:srgbClr val="063D79"/>
-                </a:solidFill>
-                <a:latin typeface="Segoe UI"/>
-              </a:rPr>
-              <a:t>192</a:t>
-            </a:r>
-          </a:p>
-        </p:txBody>
-      </p:sp>
-      <p:sp>
-        <p:nvSpPr>
-          <p:cNvPr id="10" name="TextBox 9"/>
-          <p:cNvSpPr txBox="1"/>
-          <p:nvPr/>
-        </p:nvSpPr>
-        <p:spPr>
-          <a:xfrm>
-            <a:off x="3502152" y="2377440"/>
-            <a:ext cx="2240280" cy="457200"/>
-          </a:xfrm>
-          <a:prstGeom prst="rect">
-            <a:avLst/>
-          </a:prstGeom>
-          <a:noFill/>
-        </p:spPr>
-        <p:txBody>
-          <a:bodyPr wrap="square">
-            <a:spAutoFit/>
-          </a:bodyPr>
-          <a:lstStyle/>
-          <a:p>
-            <a:pPr algn="ctr"/>
-            <a:r>
-              <a:rPr sz="1250" b="0" i="0">
-                <a:solidFill>
-                  <a:srgbClr val="1A1A1A"/>
-                </a:solidFill>
-                <a:latin typeface="Segoe UI"/>
-              </a:rPr>
-              <a:t>automated tests</a:t>
-            </a:r>
-          </a:p>
-        </p:txBody>
-      </p:sp>
-      <p:sp>
-        <p:nvSpPr>
-          <p:cNvPr id="11" name="Rounded Rectangle 10"/>
-          <p:cNvSpPr/>
-          <p:nvPr/>
-        </p:nvSpPr>
-        <p:spPr>
-          <a:xfrm>
-            <a:off x="5998464" y="1645920"/>
-            <a:ext cx="2514600" cy="1371600"/>
-          </a:xfrm>
-          <a:prstGeom prst="roundRect">
-            <a:avLst>
-              <a:gd name="adj" fmla="val 7000"/>
-            </a:avLst>
-          </a:prstGeom>
-          <a:solidFill>
-            <a:srgbClr val="FFFFFF"/>
-          </a:solidFill>
-          <a:ln w="12700">
-            <a:solidFill>
-              <a:srgbClr val="D8DADC"/>
-            </a:solidFill>
-          </a:ln>
-          <a:effectLst/>
-        </p:spPr>
-        <p:style>
-          <a:lnRef idx="1">
-            <a:schemeClr val="accent1"/>
-          </a:lnRef>
-          <a:fillRef idx="3">
-            <a:schemeClr val="accent1"/>
-          </a:fillRef>
-          <a:effectRef idx="2">
-            <a:schemeClr val="accent1"/>
-          </a:effectRef>
-          <a:fontRef idx="minor">
-            <a:schemeClr val="lt1"/>
-          </a:fontRef>
-        </p:style>
-        <p:txBody>
-          <a:bodyPr rtlCol="0" anchor="ctr"/>
-          <a:lstStyle/>
-          <a:p>
-            <a:pPr algn="ctr"/>
-            <a:endParaRPr/>
-          </a:p>
-        </p:txBody>
-      </p:sp>
-      <p:sp>
-        <p:nvSpPr>
-          <p:cNvPr id="12" name="TextBox 11"/>
-          <p:cNvSpPr txBox="1"/>
-          <p:nvPr/>
-        </p:nvSpPr>
-        <p:spPr>
-          <a:xfrm>
-            <a:off x="5998464" y="1783080"/>
-            <a:ext cx="2514600" cy="685800"/>
-          </a:xfrm>
-          <a:prstGeom prst="rect">
-            <a:avLst/>
-          </a:prstGeom>
-          <a:noFill/>
-        </p:spPr>
-        <p:txBody>
-          <a:bodyPr wrap="square">
-            <a:spAutoFit/>
-          </a:bodyPr>
-          <a:lstStyle/>
-          <a:p>
-            <a:pPr algn="ctr"/>
-            <a:r>
-              <a:rPr sz="3200" b="1" i="0">
-                <a:solidFill>
-                  <a:srgbClr val="063D79"/>
-                </a:solidFill>
-                <a:latin typeface="Segoe UI"/>
-              </a:rPr>
-              <a:t>3</a:t>
-            </a:r>
-          </a:p>
-        </p:txBody>
-      </p:sp>
-      <p:sp>
-        <p:nvSpPr>
-          <p:cNvPr id="13" name="TextBox 12"/>
-          <p:cNvSpPr txBox="1"/>
-          <p:nvPr/>
-        </p:nvSpPr>
-        <p:spPr>
-          <a:xfrm>
-            <a:off x="6135624" y="2377440"/>
-            <a:ext cx="2240280" cy="457200"/>
-          </a:xfrm>
-          <a:prstGeom prst="rect">
-            <a:avLst/>
-          </a:prstGeom>
-          <a:noFill/>
-        </p:spPr>
-        <p:txBody>
-          <a:bodyPr wrap="square">
-            <a:spAutoFit/>
-          </a:bodyPr>
-          <a:lstStyle/>
-          <a:p>
-            <a:pPr algn="ctr"/>
-            <a:r>
-              <a:rPr sz="1250" b="0" i="0">
-                <a:solidFill>
-                  <a:srgbClr val="1A1A1A"/>
-                </a:solidFill>
-                <a:latin typeface="Segoe UI"/>
-              </a:rPr>
-              <a:t>guidance modes</a:t>
-            </a:r>
-          </a:p>
-        </p:txBody>
-      </p:sp>
-      <p:sp>
-        <p:nvSpPr>
-          <p:cNvPr id="14" name="Rounded Rectangle 13"/>
-          <p:cNvSpPr/>
-          <p:nvPr/>
-        </p:nvSpPr>
-        <p:spPr>
-          <a:xfrm>
-            <a:off x="8631936" y="1645920"/>
-            <a:ext cx="2514600" cy="1371600"/>
-          </a:xfrm>
-          <a:prstGeom prst="roundRect">
-            <a:avLst>
-              <a:gd name="adj" fmla="val 7000"/>
-            </a:avLst>
-          </a:prstGeom>
-          <a:solidFill>
-            <a:srgbClr val="FFFFFF"/>
-          </a:solidFill>
-          <a:ln w="12700">
-            <a:solidFill>
-              <a:srgbClr val="D8DADC"/>
-            </a:solidFill>
-          </a:ln>
-          <a:effectLst/>
-        </p:spPr>
-        <p:style>
-          <a:lnRef idx="1">
-            <a:schemeClr val="accent1"/>
-          </a:lnRef>
-          <a:fillRef idx="3">
-            <a:schemeClr val="accent1"/>
-          </a:fillRef>
-          <a:effectRef idx="2">
-            <a:schemeClr val="accent1"/>
-          </a:effectRef>
-          <a:fontRef idx="minor">
-            <a:schemeClr val="lt1"/>
-          </a:fontRef>
-        </p:style>
-        <p:txBody>
-          <a:bodyPr rtlCol="0" anchor="ctr"/>
-          <a:lstStyle/>
-          <a:p>
-            <a:pPr algn="ctr"/>
-            <a:endParaRPr/>
-          </a:p>
-        </p:txBody>
-      </p:sp>
-      <p:sp>
-        <p:nvSpPr>
-          <p:cNvPr id="15" name="TextBox 14"/>
-          <p:cNvSpPr txBox="1"/>
-          <p:nvPr/>
-        </p:nvSpPr>
-        <p:spPr>
-          <a:xfrm>
-            <a:off x="8631936" y="1783080"/>
-            <a:ext cx="2514600" cy="685800"/>
-          </a:xfrm>
-          <a:prstGeom prst="rect">
-            <a:avLst/>
-          </a:prstGeom>
-          <a:noFill/>
-        </p:spPr>
-        <p:txBody>
-          <a:bodyPr wrap="square">
-            <a:spAutoFit/>
-          </a:bodyPr>
-          <a:lstStyle/>
-          <a:p>
-            <a:pPr algn="ctr"/>
-            <a:r>
-              <a:rPr sz="3200" b="1" i="0">
-                <a:solidFill>
-                  <a:srgbClr val="063D79"/>
-                </a:solidFill>
-                <a:latin typeface="Segoe UI"/>
-              </a:rPr>
-              <a:t>2</a:t>
-            </a:r>
-          </a:p>
-        </p:txBody>
-      </p:sp>
-      <p:sp>
-        <p:nvSpPr>
-          <p:cNvPr id="16" name="TextBox 15"/>
-          <p:cNvSpPr txBox="1"/>
-          <p:nvPr/>
-        </p:nvSpPr>
-        <p:spPr>
-          <a:xfrm>
-            <a:off x="8769096" y="2377440"/>
-            <a:ext cx="2240280" cy="457200"/>
-          </a:xfrm>
-          <a:prstGeom prst="rect">
-            <a:avLst/>
-          </a:prstGeom>
-          <a:noFill/>
-        </p:spPr>
-        <p:txBody>
-          <a:bodyPr wrap="square">
-            <a:spAutoFit/>
-          </a:bodyPr>
-          <a:lstStyle/>
-          <a:p>
-            <a:pPr algn="ctr"/>
-            <a:r>
-              <a:rPr sz="1250" b="0" i="0">
-                <a:solidFill>
-                  <a:srgbClr val="1A1A1A"/>
-                </a:solidFill>
-                <a:latin typeface="Segoe UI"/>
-              </a:rPr>
-              <a:t>platforms packaged</a:t>
-            </a:r>
-          </a:p>
-        </p:txBody>
-      </p:sp>
-      <p:graphicFrame>
-        <p:nvGraphicFramePr>
-          <p:cNvPr id="17" name="Chart 16"/>
-          <p:cNvGraphicFramePr>
-            <a:graphicFrameLocks noGrp="1"/>
-          </p:cNvGraphicFramePr>
-          <p:nvPr/>
-        </p:nvGraphicFramePr>
-        <p:xfrm>
-          <a:off x="731520" y="3246120"/>
-          <a:ext cx="5029200" cy="3200400"/>
-        </p:xfrm>
-        <a:graphic>
-          <a:graphicData uri="http://schemas.openxmlformats.org/drawingml/2006/chart">
-            <c:chart xmlns:c="http://schemas.openxmlformats.org/drawingml/2006/chart" xmlns:r="http://schemas.openxmlformats.org/officeDocument/2006/relationships" r:id="rId2"/>
-          </a:graphicData>
-        </a:graphic>
-      </p:graphicFrame>
-      <p:sp>
-        <p:nvSpPr>
-          <p:cNvPr id="18" name="Rounded Rectangle 17"/>
-          <p:cNvSpPr/>
-          <p:nvPr/>
-        </p:nvSpPr>
-        <p:spPr>
-          <a:xfrm>
-            <a:off x="6050280" y="3124200"/>
-            <a:ext cx="2968752" cy="2712720"/>
-          </a:xfrm>
-          <a:prstGeom prst="roundRect">
-            <a:avLst>
-              <a:gd name="adj" fmla="val 7000"/>
-            </a:avLst>
-          </a:prstGeom>
-          <a:solidFill>
-            <a:srgbClr val="FFFFFF"/>
-          </a:solidFill>
-          <a:ln w="12700">
-            <a:solidFill>
-              <a:srgbClr val="D8DADC"/>
-            </a:solidFill>
-          </a:ln>
-        </p:spPr>
-        <p:style>
-          <a:lnRef idx="1">
-            <a:schemeClr val="accent1"/>
-          </a:lnRef>
-          <a:fillRef idx="3">
-            <a:schemeClr val="accent1"/>
-          </a:fillRef>
-          <a:effectRef idx="2">
-            <a:schemeClr val="accent1"/>
-          </a:effectRef>
-          <a:fontRef idx="minor">
-            <a:schemeClr val="lt1"/>
-          </a:fontRef>
-        </p:style>
-        <p:txBody>
-          <a:bodyPr rtlCol="0" anchor="ctr"/>
-          <a:lstStyle/>
-          <a:p>
-            <a:pPr algn="ctr"/>
-            <a:endParaRPr/>
-          </a:p>
-        </p:txBody>
-      </p:sp>
-      <p:pic>
-        <p:nvPicPr>
-          <p:cNvPr id="19" name="Picture 18" descr="final_report.png"/>
-          <p:cNvPicPr>
-            <a:picLocks noChangeAspect="1"/>
-          </p:cNvPicPr>
-          <p:nvPr/>
-        </p:nvPicPr>
-        <p:blipFill>
-          <a:blip r:embed="rId3"/>
-          <a:stretch>
-            <a:fillRect/>
-          </a:stretch>
-        </p:blipFill>
-        <p:spPr>
-          <a:xfrm>
-            <a:off x="6126480" y="3200400"/>
-            <a:ext cx="2816352" cy="2560320"/>
-          </a:xfrm>
-          <a:prstGeom prst="rect">
-            <a:avLst/>
-          </a:prstGeom>
-        </p:spPr>
-      </p:pic>
-      <p:sp>
-        <p:nvSpPr>
-          <p:cNvPr id="20" name="TextBox 19"/>
-          <p:cNvSpPr txBox="1"/>
-          <p:nvPr/>
-        </p:nvSpPr>
-        <p:spPr>
-          <a:xfrm>
-            <a:off x="6126480" y="5862320"/>
-            <a:ext cx="5394960" cy="365760"/>
-          </a:xfrm>
-          <a:prstGeom prst="rect">
-            <a:avLst/>
-          </a:prstGeom>
-          <a:noFill/>
-        </p:spPr>
-        <p:txBody>
-          <a:bodyPr wrap="square">
-            <a:spAutoFit/>
-          </a:bodyPr>
-          <a:lstStyle/>
-          <a:p>
-            <a:pPr algn="ctr"/>
-            <a:r>
-              <a:rPr sz="1250" b="0" i="1">
-                <a:solidFill>
-                  <a:srgbClr val="3F3F3F"/>
-                </a:solidFill>
-                <a:latin typeface="Segoe UI"/>
-              </a:rPr>
-              <a:t>100% sovereignty score — real restore, 3,344 files</a:t>
-            </a:r>
-          </a:p>
-        </p:txBody>
-      </p:sp>
-    </p:spTree>
-  </p:cSld>
-  <p:clrMapOvr>
-    <a:masterClrMapping/>
-  </p:clrMapOvr>
-</p:sld>
-</file>
-
 <file path=ppt/slides/slide24.xml><?xml version="1.0" encoding="utf-8"?>
 <p:sld xmlns:a="http://schemas.openxmlformats.org/drawingml/2006/main" xmlns:r="http://schemas.openxmlformats.org/officeDocument/2006/relationships" xmlns:p="http://schemas.openxmlformats.org/presentationml/2006/main">
   <p:cSld>
@@ -24235,7 +23270,7 @@
 </file>
 
 <file path=ppt/slides/slide9.xml><?xml version="1.0" encoding="utf-8"?>
-<p:sld xmlns:a="http://schemas.openxmlformats.org/drawingml/2006/main" xmlns:p="http://schemas.openxmlformats.org/presentationml/2006/main" xmlns:r="http://schemas.openxmlformats.org/officeDocument/2006/relationships">
+<p:sld xmlns:a="http://schemas.openxmlformats.org/drawingml/2006/main" xmlns:r="http://schemas.openxmlformats.org/officeDocument/2006/relationships" xmlns:p="http://schemas.openxmlformats.org/presentationml/2006/main">
   <p:cSld>
     <p:spTree>
       <p:nvGrpSpPr>
@@ -24243,7 +23278,14 @@
         <p:cNvGrpSpPr/>
         <p:nvPr/>
       </p:nvGrpSpPr>
-      <p:grpSpPr/>
+      <p:grpSpPr>
+        <a:xfrm>
+          <a:off x="0" y="0"/>
+          <a:ext cx="0" cy="0"/>
+          <a:chOff x="0" y="0"/>
+          <a:chExt cx="0" cy="0"/>
+        </a:xfrm>
+      </p:grpSpPr>
       <p:sp>
         <p:nvSpPr>
           <p:cNvPr id="2" name="TextBox 1"/>
@@ -24355,6 +23397,7 @@
           <a:lstStyle/>
           <a:p>
             <a:pPr algn="ctr"/>
+            <a:endParaRPr/>
           </a:p>
         </p:txBody>
       </p:sp>

</xml_diff>